<commit_message>
Typeset fractions with a horizontal bar, never a slash
latex_eq rejects a/b and forces bar fractions in OMML; specs, chart rules,
SVG helper, and the sample deck follow the same rule.

Co-Authored-By: Claude Opus 5.5 <noreply@anthropic.com>
</commit_message>
<xml_diff>
--- a/examples/out/sample_16x9.pptx
+++ b/examples/out/sample_16x9.pptx
@@ -6118,8 +6118,8 @@
             </p:nvSpPr>
             <p:spPr>
               <a:xfrm>
-                <a:off x="365760" y="2240280"/>
-                <a:ext cx="6079205" cy="731520"/>
+                <a:off x="365760" y="2029968"/>
+                <a:ext cx="6079205" cy="548640"/>
               </a:xfrm>
               <a:prstGeom prst="rect">
                 <a:avLst/>
@@ -6146,7 +6146,7 @@
                             </m:barPr>
                             <m:e>
                               <m:r>
-                                <a:rPr lang="en-US" sz="2400">
+                                <a:rPr lang="en-US" sz="2000">
                                   <a:solidFill>
                                     <a:srgbClr val="1A1A1A"/>
                                   </a:solidFill>
@@ -6161,7 +6161,7 @@
                         </m:e>
                         <m:sub>
                           <m:r>
-                            <a:rPr lang="en-US" sz="2400">
+                            <a:rPr lang="en-US" sz="2000">
                               <a:solidFill>
                                 <a:srgbClr val="1A1A1A"/>
                               </a:solidFill>
@@ -6174,7 +6174,7 @@
                         </m:sub>
                       </m:sSub>
                       <m:r>
-                        <a:rPr lang="en-US" sz="2400">
+                        <a:rPr lang="en-US" sz="2000">
                           <a:solidFill>
                             <a:srgbClr val="1A1A1A"/>
                           </a:solidFill>
@@ -6190,7 +6190,7 @@
                             <m:rPr>
                               <m:sty m:val="b"/>
                             </m:rPr>
-                            <a:rPr lang="en-US" sz="2400" i="0" b="1">
+                            <a:rPr lang="en-US" sz="2000" i="0" b="1">
                               <a:solidFill>
                                 <a:srgbClr val="1A1A1A"/>
                               </a:solidFill>
@@ -6203,7 +6203,7 @@
                         </m:e>
                         <m:sub>
                           <m:r>
-                            <a:rPr lang="en-US" sz="2400">
+                            <a:rPr lang="en-US" sz="2000">
                               <a:solidFill>
                                 <a:srgbClr val="1A1A1A"/>
                               </a:solidFill>
@@ -6216,7 +6216,7 @@
                         </m:sub>
                         <m:sup>
                           <m:r>
-                            <a:rPr lang="en-US" sz="2400">
+                            <a:rPr lang="en-US" sz="2000">
                               <a:solidFill>
                                 <a:srgbClr val="1A1A1A"/>
                               </a:solidFill>
@@ -6234,7 +6234,7 @@
                             <m:dPr/>
                             <m:e>
                               <m:r>
-                                <a:rPr lang="en-US" sz="2400">
+                                <a:rPr lang="en-US" sz="2000">
                                   <a:solidFill>
                                     <a:srgbClr val="1A1A1A"/>
                                   </a:solidFill>
@@ -6247,7 +6247,7 @@
                               <m:sSubSup>
                                 <m:e>
                                   <m:r>
-                                    <a:rPr lang="en-US" sz="2400">
+                                    <a:rPr lang="en-US" sz="2000">
                                       <a:solidFill>
                                         <a:srgbClr val="1A1A1A"/>
                                       </a:solidFill>
@@ -6260,7 +6260,7 @@
                                 </m:e>
                                 <m:sub>
                                   <m:r>
-                                    <a:rPr lang="en-US" sz="2400">
+                                    <a:rPr lang="en-US" sz="2000">
                                       <a:solidFill>
                                         <a:srgbClr val="1A1A1A"/>
                                       </a:solidFill>
@@ -6273,7 +6273,7 @@
                                 </m:sub>
                                 <m:sup>
                                   <m:r>
-                                    <a:rPr lang="en-US" sz="2400">
+                                    <a:rPr lang="en-US" sz="2000">
                                       <a:solidFill>
                                         <a:srgbClr val="1A1A1A"/>
                                       </a:solidFill>
@@ -6286,7 +6286,7 @@
                                 </m:sup>
                               </m:sSubSup>
                               <m:r>
-                                <a:rPr lang="en-US" sz="2400">
+                                <a:rPr lang="en-US" sz="2000">
                                   <a:solidFill>
                                     <a:srgbClr val="1A1A1A"/>
                                   </a:solidFill>
@@ -6301,7 +6301,7 @@
                         </m:e>
                         <m:sup>
                           <m:r>
-                            <a:rPr lang="en-US" sz="2400">
+                            <a:rPr lang="en-US" sz="2000">
                               <a:solidFill>
                                 <a:srgbClr val="1A1A1A"/>
                               </a:solidFill>
@@ -6317,7 +6317,7 @@
                         <m:rPr>
                           <m:sty m:val="b"/>
                         </m:rPr>
-                        <a:rPr lang="en-US" sz="2400" i="0" b="1">
+                        <a:rPr lang="en-US" sz="2000" i="0" b="1">
                           <a:solidFill>
                             <a:srgbClr val="1A1A1A"/>
                           </a:solidFill>
@@ -6343,8 +6343,8 @@
             </p:nvSpPr>
             <p:spPr>
               <a:xfrm>
-                <a:off x="365760" y="2240280"/>
-                <a:ext cx="6079205" cy="731520"/>
+                <a:off x="365760" y="2029968"/>
+                <a:ext cx="6079205" cy="548640"/>
               </a:xfrm>
               <a:prstGeom prst="rect">
                 <a:avLst/>
@@ -6358,7 +6358,7 @@
               <a:lstStyle/>
               <a:p>
                 <a:r>
-                  <a:rPr lang="en-US" sz="1680" i="0">
+                  <a:rPr lang="en-US" sz="1400" i="0">
                     <a:solidFill>
                       <a:srgbClr val="1A1A1A"/>
                     </a:solidFill>
@@ -6381,8 +6381,8 @@
         </p:nvSpPr>
         <p:spPr>
           <a:xfrm>
-            <a:off x="6444965" y="2240280"/>
-            <a:ext cx="548640" cy="731520"/>
+            <a:off x="6444965" y="2029968"/>
+            <a:ext cx="548640" cy="548640"/>
           </a:xfrm>
           <a:prstGeom prst="rect">
             <a:avLst/>
@@ -6418,8 +6418,8 @@
             </p:nvSpPr>
             <p:spPr>
               <a:xfrm>
-                <a:off x="365760" y="3017520"/>
-                <a:ext cx="6079205" cy="731520"/>
+                <a:off x="365760" y="2596896"/>
+                <a:ext cx="6079205" cy="548640"/>
               </a:xfrm>
               <a:prstGeom prst="rect">
                 <a:avLst/>
@@ -6443,7 +6443,7 @@
                           <m:scr m:val="double-struck"/>
                           <m:sty m:val="p"/>
                         </m:rPr>
-                        <a:rPr lang="en-US" sz="2400" i="0">
+                        <a:rPr lang="en-US" sz="2000" i="0">
                           <a:solidFill>
                             <a:srgbClr val="1A1A1A"/>
                           </a:solidFill>
@@ -6454,7 +6454,7 @@
                         <m:t>V</m:t>
                       </m:r>
                       <m:r>
-                        <a:rPr lang="en-US" sz="2400">
+                        <a:rPr lang="en-US" sz="2000">
                           <a:solidFill>
                             <a:srgbClr val="1A1A1A"/>
                           </a:solidFill>
@@ -6467,7 +6467,7 @@
                       <m:sSub>
                         <m:e>
                           <m:r>
-                            <a:rPr lang="en-US" sz="2400">
+                            <a:rPr lang="en-US" sz="2000">
                               <a:solidFill>
                                 <a:srgbClr val="1A1A1A"/>
                               </a:solidFill>
@@ -6480,7 +6480,7 @@
                         </m:e>
                         <m:sub>
                           <m:r>
-                            <a:rPr lang="en-US" sz="2400">
+                            <a:rPr lang="en-US" sz="2000">
                               <a:solidFill>
                                 <a:srgbClr val="1A1A1A"/>
                               </a:solidFill>
@@ -6493,7 +6493,7 @@
                         </m:sub>
                       </m:sSub>
                       <m:r>
-                        <a:rPr lang="en-US" sz="2400">
+                        <a:rPr lang="en-US" sz="2000">
                           <a:solidFill>
                             <a:srgbClr val="1A1A1A"/>
                           </a:solidFill>
@@ -6509,7 +6509,7 @@
                             <m:rPr>
                               <m:sty m:val="b"/>
                             </m:rPr>
-                            <a:rPr lang="en-US" sz="2400" i="0" b="1">
+                            <a:rPr lang="en-US" sz="2000" i="0" b="1">
                               <a:solidFill>
                                 <a:srgbClr val="1A1A1A"/>
                               </a:solidFill>
@@ -6522,7 +6522,7 @@
                         </m:e>
                         <m:sub>
                           <m:r>
-                            <a:rPr lang="en-US" sz="2400">
+                            <a:rPr lang="en-US" sz="2000">
                               <a:solidFill>
                                 <a:srgbClr val="1A1A1A"/>
                               </a:solidFill>
@@ -6535,7 +6535,7 @@
                         </m:sub>
                       </m:sSub>
                       <m:r>
-                        <a:rPr lang="en-US" sz="2400">
+                        <a:rPr lang="en-US" sz="2000">
                           <a:solidFill>
                             <a:srgbClr val="1A1A1A"/>
                           </a:solidFill>
@@ -6551,7 +6551,7 @@
                             <m:rPr>
                               <m:sty m:val="b"/>
                             </m:rPr>
-                            <a:rPr lang="en-US" sz="2400" i="0" b="1">
+                            <a:rPr lang="en-US" sz="2000" i="0" b="1">
                               <a:solidFill>
                                 <a:srgbClr val="1A1A1A"/>
                               </a:solidFill>
@@ -6564,7 +6564,7 @@
                         </m:e>
                         <m:sub>
                           <m:r>
-                            <a:rPr lang="en-US" sz="2400">
+                            <a:rPr lang="en-US" sz="2000">
                               <a:solidFill>
                                 <a:srgbClr val="1A1A1A"/>
                               </a:solidFill>
@@ -6577,7 +6577,7 @@
                         </m:sub>
                       </m:sSub>
                       <m:r>
-                        <a:rPr lang="en-US" sz="2400">
+                        <a:rPr lang="en-US" sz="2000">
                           <a:solidFill>
                             <a:srgbClr val="1A1A1A"/>
                           </a:solidFill>
@@ -6593,7 +6593,7 @@
                             <m:rPr>
                               <m:sty m:val="b"/>
                             </m:rPr>
-                            <a:rPr lang="en-US" sz="2400" i="0" b="1">
+                            <a:rPr lang="en-US" sz="2000" i="0" b="1">
                               <a:solidFill>
                                 <a:srgbClr val="1A1A1A"/>
                               </a:solidFill>
@@ -6606,7 +6606,7 @@
                         </m:e>
                         <m:sub>
                           <m:r>
-                            <a:rPr lang="en-US" sz="2400">
+                            <a:rPr lang="en-US" sz="2000">
                               <a:solidFill>
                                 <a:srgbClr val="1A1A1A"/>
                               </a:solidFill>
@@ -6619,7 +6619,7 @@
                         </m:sub>
                         <m:sup>
                           <m:r>
-                            <a:rPr lang="en-US" sz="2400">
+                            <a:rPr lang="en-US" sz="2000">
                               <a:solidFill>
                                 <a:srgbClr val="1A1A1A"/>
                               </a:solidFill>
@@ -6637,7 +6637,7 @@
                             <m:dPr/>
                             <m:e>
                               <m:r>
-                                <a:rPr lang="en-US" sz="2400">
+                                <a:rPr lang="en-US" sz="2000">
                                   <a:solidFill>
                                     <a:srgbClr val="1A1A1A"/>
                                   </a:solidFill>
@@ -6650,7 +6650,7 @@
                               <m:sSubSup>
                                 <m:e>
                                   <m:r>
-                                    <a:rPr lang="en-US" sz="2400">
+                                    <a:rPr lang="en-US" sz="2000">
                                       <a:solidFill>
                                         <a:srgbClr val="1A1A1A"/>
                                       </a:solidFill>
@@ -6663,7 +6663,7 @@
                                 </m:e>
                                 <m:sub>
                                   <m:r>
-                                    <a:rPr lang="en-US" sz="2400">
+                                    <a:rPr lang="en-US" sz="2000">
                                       <a:solidFill>
                                         <a:srgbClr val="1A1A1A"/>
                                       </a:solidFill>
@@ -6676,7 +6676,7 @@
                                 </m:sub>
                                 <m:sup>
                                   <m:r>
-                                    <a:rPr lang="en-US" sz="2400">
+                                    <a:rPr lang="en-US" sz="2000">
                                       <a:solidFill>
                                         <a:srgbClr val="1A1A1A"/>
                                       </a:solidFill>
@@ -6689,7 +6689,7 @@
                                 </m:sup>
                               </m:sSubSup>
                               <m:r>
-                                <a:rPr lang="en-US" sz="2400">
+                                <a:rPr lang="en-US" sz="2000">
                                   <a:solidFill>
                                     <a:srgbClr val="1A1A1A"/>
                                   </a:solidFill>
@@ -6704,7 +6704,7 @@
                         </m:e>
                         <m:sup>
                           <m:r>
-                            <a:rPr lang="en-US" sz="2400">
+                            <a:rPr lang="en-US" sz="2000">
                               <a:solidFill>
                                 <a:srgbClr val="1A1A1A"/>
                               </a:solidFill>
@@ -6722,7 +6722,7 @@
                             <m:rPr>
                               <m:sty m:val="b"/>
                             </m:rPr>
-                            <a:rPr lang="en-US" sz="2400" i="0" b="1">
+                            <a:rPr lang="en-US" sz="2000" i="0" b="1">
                               <a:solidFill>
                                 <a:srgbClr val="1A1A1A"/>
                               </a:solidFill>
@@ -6735,7 +6735,7 @@
                         </m:e>
                         <m:sub>
                           <m:r>
-                            <a:rPr lang="en-US" sz="2400">
+                            <a:rPr lang="en-US" sz="2000">
                               <a:solidFill>
                                 <a:srgbClr val="1A1A1A"/>
                               </a:solidFill>
@@ -6763,8 +6763,8 @@
             </p:nvSpPr>
             <p:spPr>
               <a:xfrm>
-                <a:off x="365760" y="3017520"/>
-                <a:ext cx="6079205" cy="731520"/>
+                <a:off x="365760" y="2596896"/>
+                <a:ext cx="6079205" cy="548640"/>
               </a:xfrm>
               <a:prstGeom prst="rect">
                 <a:avLst/>
@@ -6778,7 +6778,7 @@
               <a:lstStyle/>
               <a:p>
                 <a:r>
-                  <a:rPr lang="en-US" sz="1680" i="0">
+                  <a:rPr lang="en-US" sz="1400" i="0">
                     <a:solidFill>
                       <a:srgbClr val="1A1A1A"/>
                     </a:solidFill>
@@ -6801,8 +6801,8 @@
         </p:nvSpPr>
         <p:spPr>
           <a:xfrm>
-            <a:off x="6444965" y="3017520"/>
-            <a:ext cx="548640" cy="731520"/>
+            <a:off x="6444965" y="2596896"/>
+            <a:ext cx="548640" cy="548640"/>
           </a:xfrm>
           <a:prstGeom prst="rect">
             <a:avLst/>
@@ -6828,15 +6828,323 @@
           </a:p>
         </p:txBody>
       </p:sp>
-      <p:sp>
-        <p:nvSpPr>
-          <p:cNvPr id="29" name="TextBox 28"/>
+      <mc:AlternateContent xmlns:mc="http://schemas.openxmlformats.org/markup-compatibility/2006">
+        <mc:Choice xmlns:a14="http://schemas.microsoft.com/office/drawing/2010/main" Requires="a14">
+          <p:sp>
+            <p:nvSpPr>
+              <p:cNvPr id="29" name="TextBox 28" descr="LaTeX: \mathrm{RMSE} = \sqrt{\frac{1}{N}\sum_{i=1}^{N}\left(y_{i} - \hat{y}_{i}\right)^{2}}"/>
+              <p:cNvSpPr txBox="1"/>
+              <p:nvPr/>
+            </p:nvSpPr>
+            <p:spPr>
+              <a:xfrm>
+                <a:off x="365760" y="3200400"/>
+                <a:ext cx="6079205" cy="1097280"/>
+              </a:xfrm>
+              <a:prstGeom prst="rect">
+                <a:avLst/>
+              </a:prstGeom>
+              <a:noFill/>
+            </p:spPr>
+            <p:txBody>
+              <a:bodyPr wrap="square" anchor="ctr" lIns="0" rIns="0" tIns="0" bIns="0">
+                <a:spAutoFit/>
+              </a:bodyPr>
+              <a:lstStyle/>
+              <a:p>
+                <a14:m>
+                  <m:oMathPara xmlns:m="http://schemas.openxmlformats.org/officeDocument/2006/math">
+                    <m:oMathParaPr>
+                      <m:jc m:val="centerGroup"/>
+                    </m:oMathParaPr>
+                    <m:oMath>
+                      <m:r>
+                        <m:rPr>
+                          <m:sty m:val="p"/>
+                        </m:rPr>
+                        <a:rPr lang="en-US" sz="2000" i="0">
+                          <a:solidFill>
+                            <a:srgbClr val="1A1A1A"/>
+                          </a:solidFill>
+                          <a:latin typeface="Cambria Math"/>
+                          <a:ea typeface="Cambria Math"/>
+                          <a:cs typeface="Cambria Math"/>
+                        </a:rPr>
+                        <m:t>RMSE</m:t>
+                      </m:r>
+                      <m:r>
+                        <a:rPr lang="en-US" sz="2000">
+                          <a:solidFill>
+                            <a:srgbClr val="1A1A1A"/>
+                          </a:solidFill>
+                          <a:latin typeface="Cambria Math"/>
+                          <a:ea typeface="Cambria Math"/>
+                          <a:cs typeface="Cambria Math"/>
+                        </a:rPr>
+                        <m:t>=</m:t>
+                      </m:r>
+                      <m:rad>
+                        <m:radPr>
+                          <m:degHide m:val="on"/>
+                        </m:radPr>
+                        <m:deg/>
+                        <m:e>
+                          <m:f>
+                            <m:fPr>
+                              <m:type m:val="bar"/>
+                            </m:fPr>
+                            <m:num>
+                              <m:r>
+                                <a:rPr lang="en-US" sz="2000">
+                                  <a:solidFill>
+                                    <a:srgbClr val="1A1A1A"/>
+                                  </a:solidFill>
+                                  <a:latin typeface="Cambria Math"/>
+                                  <a:ea typeface="Cambria Math"/>
+                                  <a:cs typeface="Cambria Math"/>
+                                </a:rPr>
+                                <m:t>1</m:t>
+                              </m:r>
+                            </m:num>
+                            <m:den>
+                              <m:r>
+                                <a:rPr lang="en-US" sz="2000">
+                                  <a:solidFill>
+                                    <a:srgbClr val="1A1A1A"/>
+                                  </a:solidFill>
+                                  <a:latin typeface="Cambria Math"/>
+                                  <a:ea typeface="Cambria Math"/>
+                                  <a:cs typeface="Cambria Math"/>
+                                </a:rPr>
+                                <m:t>N</m:t>
+                              </m:r>
+                            </m:den>
+                          </m:f>
+                          <m:nary>
+                            <m:naryPr>
+                              <m:chr m:val="∑"/>
+                              <m:limLoc m:val="undOvr"/>
+                              <m:grow m:val="1"/>
+                              <m:subHide m:val="off"/>
+                              <m:supHide m:val="off"/>
+                            </m:naryPr>
+                            <m:sub>
+                              <m:r>
+                                <a:rPr lang="en-US" sz="2000">
+                                  <a:solidFill>
+                                    <a:srgbClr val="1A1A1A"/>
+                                  </a:solidFill>
+                                  <a:latin typeface="Cambria Math"/>
+                                  <a:ea typeface="Cambria Math"/>
+                                  <a:cs typeface="Cambria Math"/>
+                                </a:rPr>
+                                <m:t>i=1</m:t>
+                              </m:r>
+                            </m:sub>
+                            <m:sup>
+                              <m:r>
+                                <a:rPr lang="en-US" sz="2000">
+                                  <a:solidFill>
+                                    <a:srgbClr val="1A1A1A"/>
+                                  </a:solidFill>
+                                  <a:latin typeface="Cambria Math"/>
+                                  <a:ea typeface="Cambria Math"/>
+                                  <a:cs typeface="Cambria Math"/>
+                                </a:rPr>
+                                <m:t>N</m:t>
+                              </m:r>
+                            </m:sup>
+                            <m:e>
+                              <m:sSup>
+                                <m:e>
+                                  <m:d>
+                                    <m:dPr/>
+                                    <m:e>
+                                      <m:sSub>
+                                        <m:e>
+                                          <m:r>
+                                            <a:rPr lang="en-US" sz="2000">
+                                              <a:solidFill>
+                                                <a:srgbClr val="1A1A1A"/>
+                                              </a:solidFill>
+                                              <a:latin typeface="Cambria Math"/>
+                                              <a:ea typeface="Cambria Math"/>
+                                              <a:cs typeface="Cambria Math"/>
+                                            </a:rPr>
+                                            <m:t>y</m:t>
+                                          </m:r>
+                                        </m:e>
+                                        <m:sub>
+                                          <m:r>
+                                            <a:rPr lang="en-US" sz="2000">
+                                              <a:solidFill>
+                                                <a:srgbClr val="1A1A1A"/>
+                                              </a:solidFill>
+                                              <a:latin typeface="Cambria Math"/>
+                                              <a:ea typeface="Cambria Math"/>
+                                              <a:cs typeface="Cambria Math"/>
+                                            </a:rPr>
+                                            <m:t>i</m:t>
+                                          </m:r>
+                                        </m:sub>
+                                      </m:sSub>
+                                      <m:r>
+                                        <a:rPr lang="en-US" sz="2000">
+                                          <a:solidFill>
+                                            <a:srgbClr val="1A1A1A"/>
+                                          </a:solidFill>
+                                          <a:latin typeface="Cambria Math"/>
+                                          <a:ea typeface="Cambria Math"/>
+                                          <a:cs typeface="Cambria Math"/>
+                                        </a:rPr>
+                                        <m:t>−</m:t>
+                                      </m:r>
+                                      <m:sSub>
+                                        <m:e>
+                                          <m:acc>
+                                            <m:accPr>
+                                              <m:chr m:val="̂"/>
+                                            </m:accPr>
+                                            <m:e>
+                                              <m:r>
+                                                <a:rPr lang="en-US" sz="2000">
+                                                  <a:solidFill>
+                                                    <a:srgbClr val="1A1A1A"/>
+                                                  </a:solidFill>
+                                                  <a:latin typeface="Cambria Math"/>
+                                                  <a:ea typeface="Cambria Math"/>
+                                                  <a:cs typeface="Cambria Math"/>
+                                                </a:rPr>
+                                                <m:t>y</m:t>
+                                              </m:r>
+                                            </m:e>
+                                          </m:acc>
+                                        </m:e>
+                                        <m:sub>
+                                          <m:r>
+                                            <a:rPr lang="en-US" sz="2000">
+                                              <a:solidFill>
+                                                <a:srgbClr val="1A1A1A"/>
+                                              </a:solidFill>
+                                              <a:latin typeface="Cambria Math"/>
+                                              <a:ea typeface="Cambria Math"/>
+                                              <a:cs typeface="Cambria Math"/>
+                                            </a:rPr>
+                                            <m:t>i</m:t>
+                                          </m:r>
+                                        </m:sub>
+                                      </m:sSub>
+                                    </m:e>
+                                  </m:d>
+                                </m:e>
+                                <m:sup>
+                                  <m:r>
+                                    <a:rPr lang="en-US" sz="2000">
+                                      <a:solidFill>
+                                        <a:srgbClr val="1A1A1A"/>
+                                      </a:solidFill>
+                                      <a:latin typeface="Cambria Math"/>
+                                      <a:ea typeface="Cambria Math"/>
+                                      <a:cs typeface="Cambria Math"/>
+                                    </a:rPr>
+                                    <m:t>2</m:t>
+                                  </m:r>
+                                </m:sup>
+                              </m:sSup>
+                            </m:e>
+                          </m:nary>
+                        </m:e>
+                      </m:rad>
+                    </m:oMath>
+                  </m:oMathPara>
+                </a14:m>
+              </a:p>
+            </p:txBody>
+          </p:sp>
+        </mc:Choice>
+        <mc:Fallback>
+          <p:sp>
+            <p:nvSpPr>
+              <p:cNvPr id="29" name="TextBox 28" descr="LaTeX: \mathrm{RMSE} = \sqrt{\frac{1}{N}\sum_{i=1}^{N}\left(y_{i} - \hat{y}_{i}\right)^{2}}"/>
+              <p:cNvSpPr txBox="1"/>
+              <p:nvPr/>
+            </p:nvSpPr>
+            <p:spPr>
+              <a:xfrm>
+                <a:off x="365760" y="3200400"/>
+                <a:ext cx="6079205" cy="1097280"/>
+              </a:xfrm>
+              <a:prstGeom prst="rect">
+                <a:avLst/>
+              </a:prstGeom>
+              <a:noFill/>
+            </p:spPr>
+            <p:txBody>
+              <a:bodyPr wrap="square" anchor="ctr" lIns="0" rIns="0" tIns="0" bIns="0">
+                <a:spAutoFit/>
+              </a:bodyPr>
+              <a:lstStyle/>
+              <a:p>
+                <a:r>
+                  <a:rPr lang="en-US" sz="1400" i="0">
+                    <a:solidFill>
+                      <a:srgbClr val="1A1A1A"/>
+                    </a:solidFill>
+                    <a:latin typeface="Cambria Math"/>
+                    <a:ea typeface="Cambria Math"/>
+                    <a:cs typeface="Cambria Math"/>
+                  </a:rPr>
+                  <a:t>\mathrm{RMSE} = \sqrt{\frac{1}{N}\sum_{i=1}^{N}\left(y_{i} - \hat{y}_{i}\right)^{2}}</a:t>
+                </a:r>
+              </a:p>
+            </p:txBody>
+          </p:sp>
+        </mc:Fallback>
+      </mc:AlternateContent>
+      <p:sp>
+        <p:nvSpPr>
+          <p:cNvPr id="30" name="TextBox 29"/>
           <p:cNvSpPr txBox="1"/>
           <p:nvPr/>
         </p:nvSpPr>
         <p:spPr>
           <a:xfrm>
-            <a:off x="365760" y="3822191"/>
+            <a:off x="6444965" y="3200400"/>
+            <a:ext cx="548640" cy="1097280"/>
+          </a:xfrm>
+          <a:prstGeom prst="rect">
+            <a:avLst/>
+          </a:prstGeom>
+          <a:noFill/>
+        </p:spPr>
+        <p:txBody>
+          <a:bodyPr wrap="none" anchor="ctr" lIns="0" rIns="0" tIns="0" bIns="0">
+            <a:spAutoFit/>
+          </a:bodyPr>
+          <a:lstStyle/>
+          <a:p>
+            <a:pPr algn="r"/>
+            <a:r>
+              <a:rPr sz="1200">
+                <a:solidFill>
+                  <a:srgbClr val="404040"/>
+                </a:solidFill>
+                <a:latin typeface="Hiragino Kaku Gothic ProN W3"/>
+              </a:rPr>
+              <a:t>(3)</a:t>
+            </a:r>
+          </a:p>
+        </p:txBody>
+      </p:sp>
+      <p:sp>
+        <p:nvSpPr>
+          <p:cNvPr id="31" name="TextBox 30"/>
+          <p:cNvSpPr txBox="1"/>
+          <p:nvPr/>
+        </p:nvSpPr>
+        <p:spPr>
+          <a:xfrm>
+            <a:off x="365760" y="4334256"/>
             <a:ext cx="6627845" cy="274320"/>
           </a:xfrm>
           <a:prstGeom prst="rect">
@@ -6864,14 +7172,14 @@
                 <a:ea typeface="Hiragino Kaku Gothic ProN W3"/>
                 <a:cs typeface="Hiragino Kaku Gothic ProN W3"/>
               </a:rPr>
-              <a:t>式 (1)(2) は GPR の予測平均と予測分散 [1]。95% 区間は平均 ± 1.96σ</a:t>
+              <a:t>(1)(2) GPR の予測平均・予測分散 [1]、(3) 評価指標の定義</a:t>
             </a:r>
           </a:p>
         </p:txBody>
       </p:sp>
       <p:graphicFrame>
         <p:nvGraphicFramePr>
-          <p:cNvPr id="30" name="Table 29"/>
+          <p:cNvPr id="32" name="Table 31"/>
           <p:cNvGraphicFramePr>
             <a:graphicFrameLocks noGrp="1"/>
           </p:cNvGraphicFramePr>
@@ -6879,7 +7187,7 @@
         </p:nvGraphicFramePr>
         <p:xfrm>
           <a:off x="7130765" y="2194560"/>
-          <a:ext cx="4695167" cy="1975104"/>
+          <a:ext cx="4695167" cy="2414016"/>
         </p:xfrm>
         <a:graphic>
           <a:graphicData uri="http://schemas.openxmlformats.org/drawingml/2006/table">
@@ -6892,7 +7200,7 @@
                 <a:gridCol w="2957956"/>
                 <a:gridCol w="939033"/>
               </a:tblGrid>
-              <a:tr h="329184">
+              <a:tr h="301752">
                 <a:tc>
                   <a:txBody>
                     <a:bodyPr wrap="square"/>
@@ -7029,7 +7337,7 @@
                   </a:tcPr>
                 </a:tc>
               </a:tr>
-              <a:tr h="329184">
+              <a:tr h="301752">
                 <a:tc>
                   <a:txBody>
                     <a:bodyPr wrap="square"/>
@@ -7166,7 +7474,7 @@
                   </a:tcPr>
                 </a:tc>
               </a:tr>
-              <a:tr h="329184">
+              <a:tr h="301752">
                 <a:tc>
                   <a:txBody>
                     <a:bodyPr wrap="square"/>
@@ -7303,7 +7611,7 @@
                   </a:tcPr>
                 </a:tc>
               </a:tr>
-              <a:tr h="329184">
+              <a:tr h="301752">
                 <a:tc>
                   <a:txBody>
                     <a:bodyPr wrap="square"/>
@@ -7440,7 +7748,7 @@
                   </a:tcPr>
                 </a:tc>
               </a:tr>
-              <a:tr h="329184">
+              <a:tr h="301752">
                 <a:tc>
                   <a:txBody>
                     <a:bodyPr wrap="square"/>
@@ -7577,7 +7885,7 @@
                   </a:tcPr>
                 </a:tc>
               </a:tr>
-              <a:tr h="329184">
+              <a:tr h="301752">
                 <a:tc>
                   <a:txBody>
                     <a:bodyPr wrap="square"/>
@@ -7613,7 +7921,7 @@
                       </a:solidFill>
                       <a:prstDash val="solid"/>
                     </a:lnT>
-                    <a:lnB w="12700" cap="flat" cmpd="sng">
+                    <a:lnB w="6350" cap="flat" cmpd="sng">
                       <a:solidFill>
                         <a:srgbClr val="1A1A1A"/>
                       </a:solidFill>
@@ -7660,7 +7968,7 @@
                       </a:solidFill>
                       <a:prstDash val="solid"/>
                     </a:lnT>
-                    <a:lnB w="12700" cap="flat" cmpd="sng">
+                    <a:lnB w="6350" cap="flat" cmpd="sng">
                       <a:solidFill>
                         <a:srgbClr val="1A1A1A"/>
                       </a:solidFill>
@@ -7704,6 +8012,280 @@
                       </a:solidFill>
                       <a:prstDash val="solid"/>
                     </a:lnT>
+                    <a:lnB w="6350" cap="flat" cmpd="sng">
+                      <a:solidFill>
+                        <a:srgbClr val="1A1A1A"/>
+                      </a:solidFill>
+                      <a:prstDash val="solid"/>
+                    </a:lnB>
+                    <a:noFill/>
+                  </a:tcPr>
+                </a:tc>
+              </a:tr>
+              <a:tr h="301752">
+                <a:tc>
+                  <a:txBody>
+                    <a:bodyPr wrap="square"/>
+                    <a:lstStyle/>
+                    <a:p>
+                      <a:pPr algn="l"/>
+                      <a:r>
+                        <a:rPr sz="1400" b="0">
+                          <a:solidFill>
+                            <a:srgbClr val="1A1A1A"/>
+                          </a:solidFill>
+                          <a:latin typeface="Hiragino Kaku Gothic ProN W3"/>
+                          <a:ea typeface="Hiragino Kaku Gothic ProN W3"/>
+                          <a:cs typeface="Hiragino Kaku Gothic ProN W3"/>
+                        </a:rPr>
+                        <a:t>N</a:t>
+                      </a:r>
+                    </a:p>
+                  </a:txBody>
+                  <a:tcPr marL="54864" marR="54864" marT="27432" marB="27432" anchor="ctr">
+                    <a:lnL w="0">
+                      <a:noFill/>
+                    </a:lnL>
+                    <a:lnR w="6350" cap="flat" cmpd="sng">
+                      <a:solidFill>
+                        <a:srgbClr val="1A1A1A"/>
+                      </a:solidFill>
+                      <a:prstDash val="solid"/>
+                    </a:lnR>
+                    <a:lnT w="6350" cap="flat" cmpd="sng">
+                      <a:solidFill>
+                        <a:srgbClr val="1A1A1A"/>
+                      </a:solidFill>
+                      <a:prstDash val="solid"/>
+                    </a:lnT>
+                    <a:lnB w="6350" cap="flat" cmpd="sng">
+                      <a:solidFill>
+                        <a:srgbClr val="1A1A1A"/>
+                      </a:solidFill>
+                      <a:prstDash val="solid"/>
+                    </a:lnB>
+                    <a:noFill/>
+                  </a:tcPr>
+                </a:tc>
+                <a:tc>
+                  <a:txBody>
+                    <a:bodyPr wrap="square"/>
+                    <a:lstStyle/>
+                    <a:p>
+                      <a:pPr algn="l"/>
+                      <a:r>
+                        <a:rPr sz="1400" b="0">
+                          <a:solidFill>
+                            <a:srgbClr val="1A1A1A"/>
+                          </a:solidFill>
+                          <a:latin typeface="Hiragino Kaku Gothic ProN W3"/>
+                          <a:ea typeface="Hiragino Kaku Gothic ProN W3"/>
+                          <a:cs typeface="Hiragino Kaku Gothic ProN W3"/>
+                        </a:rPr>
+                        <a:t>テスト点の数(200)</a:t>
+                      </a:r>
+                    </a:p>
+                  </a:txBody>
+                  <a:tcPr marL="54864" marR="54864" marT="27432" marB="27432" anchor="ctr">
+                    <a:lnL w="6350" cap="flat" cmpd="sng">
+                      <a:solidFill>
+                        <a:srgbClr val="1A1A1A"/>
+                      </a:solidFill>
+                      <a:prstDash val="solid"/>
+                    </a:lnL>
+                    <a:lnR w="6350" cap="flat" cmpd="sng">
+                      <a:solidFill>
+                        <a:srgbClr val="1A1A1A"/>
+                      </a:solidFill>
+                      <a:prstDash val="solid"/>
+                    </a:lnR>
+                    <a:lnT w="6350" cap="flat" cmpd="sng">
+                      <a:solidFill>
+                        <a:srgbClr val="1A1A1A"/>
+                      </a:solidFill>
+                      <a:prstDash val="solid"/>
+                    </a:lnT>
+                    <a:lnB w="6350" cap="flat" cmpd="sng">
+                      <a:solidFill>
+                        <a:srgbClr val="1A1A1A"/>
+                      </a:solidFill>
+                      <a:prstDash val="solid"/>
+                    </a:lnB>
+                    <a:noFill/>
+                  </a:tcPr>
+                </a:tc>
+                <a:tc>
+                  <a:txBody>
+                    <a:bodyPr wrap="square"/>
+                    <a:lstStyle/>
+                    <a:p>
+                      <a:pPr algn="l"/>
+                      <a:r>
+                        <a:rPr sz="1400" b="0">
+                          <a:solidFill>
+                            <a:srgbClr val="1A1A1A"/>
+                          </a:solidFill>
+                          <a:latin typeface="Hiragino Kaku Gothic ProN W3"/>
+                          <a:ea typeface="Hiragino Kaku Gothic ProN W3"/>
+                          <a:cs typeface="Hiragino Kaku Gothic ProN W3"/>
+                        </a:rPr>
+                        <a:t>点</a:t>
+                      </a:r>
+                    </a:p>
+                  </a:txBody>
+                  <a:tcPr marL="54864" marR="54864" marT="27432" marB="27432" anchor="ctr">
+                    <a:lnL w="6350" cap="flat" cmpd="sng">
+                      <a:solidFill>
+                        <a:srgbClr val="1A1A1A"/>
+                      </a:solidFill>
+                      <a:prstDash val="solid"/>
+                    </a:lnL>
+                    <a:lnR w="0">
+                      <a:noFill/>
+                    </a:lnR>
+                    <a:lnT w="6350" cap="flat" cmpd="sng">
+                      <a:solidFill>
+                        <a:srgbClr val="1A1A1A"/>
+                      </a:solidFill>
+                      <a:prstDash val="solid"/>
+                    </a:lnT>
+                    <a:lnB w="6350" cap="flat" cmpd="sng">
+                      <a:solidFill>
+                        <a:srgbClr val="1A1A1A"/>
+                      </a:solidFill>
+                      <a:prstDash val="solid"/>
+                    </a:lnB>
+                    <a:noFill/>
+                  </a:tcPr>
+                </a:tc>
+              </a:tr>
+              <a:tr h="301752">
+                <a:tc>
+                  <a:txBody>
+                    <a:bodyPr wrap="square"/>
+                    <a:lstStyle/>
+                    <a:p>
+                      <a:pPr algn="l"/>
+                      <a:r>
+                        <a:rPr sz="1400" b="0">
+                          <a:solidFill>
+                            <a:srgbClr val="1A1A1A"/>
+                          </a:solidFill>
+                          <a:latin typeface="Hiragino Kaku Gothic ProN W3"/>
+                          <a:ea typeface="Hiragino Kaku Gothic ProN W3"/>
+                          <a:cs typeface="Hiragino Kaku Gothic ProN W3"/>
+                        </a:rPr>
+                        <a:t>yi, ŷi</a:t>
+                      </a:r>
+                    </a:p>
+                  </a:txBody>
+                  <a:tcPr marL="54864" marR="54864" marT="27432" marB="27432" anchor="ctr">
+                    <a:lnL w="0">
+                      <a:noFill/>
+                    </a:lnL>
+                    <a:lnR w="6350" cap="flat" cmpd="sng">
+                      <a:solidFill>
+                        <a:srgbClr val="1A1A1A"/>
+                      </a:solidFill>
+                      <a:prstDash val="solid"/>
+                    </a:lnR>
+                    <a:lnT w="6350" cap="flat" cmpd="sng">
+                      <a:solidFill>
+                        <a:srgbClr val="1A1A1A"/>
+                      </a:solidFill>
+                      <a:prstDash val="solid"/>
+                    </a:lnT>
+                    <a:lnB w="12700" cap="flat" cmpd="sng">
+                      <a:solidFill>
+                        <a:srgbClr val="1A1A1A"/>
+                      </a:solidFill>
+                      <a:prstDash val="solid"/>
+                    </a:lnB>
+                    <a:noFill/>
+                  </a:tcPr>
+                </a:tc>
+                <a:tc>
+                  <a:txBody>
+                    <a:bodyPr wrap="square"/>
+                    <a:lstStyle/>
+                    <a:p>
+                      <a:pPr algn="l"/>
+                      <a:r>
+                        <a:rPr sz="1400" b="0">
+                          <a:solidFill>
+                            <a:srgbClr val="1A1A1A"/>
+                          </a:solidFill>
+                          <a:latin typeface="Hiragino Kaku Gothic ProN W3"/>
+                          <a:ea typeface="Hiragino Kaku Gothic ProN W3"/>
+                          <a:cs typeface="Hiragino Kaku Gothic ProN W3"/>
+                        </a:rPr>
+                        <a:t>i 番目の真値と予測値</a:t>
+                      </a:r>
+                    </a:p>
+                  </a:txBody>
+                  <a:tcPr marL="54864" marR="54864" marT="27432" marB="27432" anchor="ctr">
+                    <a:lnL w="6350" cap="flat" cmpd="sng">
+                      <a:solidFill>
+                        <a:srgbClr val="1A1A1A"/>
+                      </a:solidFill>
+                      <a:prstDash val="solid"/>
+                    </a:lnL>
+                    <a:lnR w="6350" cap="flat" cmpd="sng">
+                      <a:solidFill>
+                        <a:srgbClr val="1A1A1A"/>
+                      </a:solidFill>
+                      <a:prstDash val="solid"/>
+                    </a:lnR>
+                    <a:lnT w="6350" cap="flat" cmpd="sng">
+                      <a:solidFill>
+                        <a:srgbClr val="1A1A1A"/>
+                      </a:solidFill>
+                      <a:prstDash val="solid"/>
+                    </a:lnT>
+                    <a:lnB w="12700" cap="flat" cmpd="sng">
+                      <a:solidFill>
+                        <a:srgbClr val="1A1A1A"/>
+                      </a:solidFill>
+                      <a:prstDash val="solid"/>
+                    </a:lnB>
+                    <a:noFill/>
+                  </a:tcPr>
+                </a:tc>
+                <a:tc>
+                  <a:txBody>
+                    <a:bodyPr wrap="square"/>
+                    <a:lstStyle/>
+                    <a:p>
+                      <a:pPr algn="l"/>
+                      <a:r>
+                        <a:rPr sz="1400" b="0">
+                          <a:solidFill>
+                            <a:srgbClr val="1A1A1A"/>
+                          </a:solidFill>
+                          <a:latin typeface="Hiragino Kaku Gothic ProN W3"/>
+                          <a:ea typeface="Hiragino Kaku Gothic ProN W3"/>
+                          <a:cs typeface="Hiragino Kaku Gothic ProN W3"/>
+                        </a:rPr>
+                        <a:t>任意</a:t>
+                      </a:r>
+                    </a:p>
+                  </a:txBody>
+                  <a:tcPr marL="54864" marR="54864" marT="27432" marB="27432" anchor="ctr">
+                    <a:lnL w="6350" cap="flat" cmpd="sng">
+                      <a:solidFill>
+                        <a:srgbClr val="1A1A1A"/>
+                      </a:solidFill>
+                      <a:prstDash val="solid"/>
+                    </a:lnL>
+                    <a:lnR w="0">
+                      <a:noFill/>
+                    </a:lnR>
+                    <a:lnT w="6350" cap="flat" cmpd="sng">
+                      <a:solidFill>
+                        <a:srgbClr val="1A1A1A"/>
+                      </a:solidFill>
+                      <a:prstDash val="solid"/>
+                    </a:lnT>
                     <a:lnB w="12700" cap="flat" cmpd="sng">
                       <a:solidFill>
                         <a:srgbClr val="1A1A1A"/>
@@ -7720,15 +8302,15 @@
       </p:graphicFrame>
       <p:graphicFrame>
         <p:nvGraphicFramePr>
-          <p:cNvPr id="31" name="Table 30"/>
+          <p:cNvPr id="33" name="Table 32"/>
           <p:cNvGraphicFramePr>
             <a:graphicFrameLocks noGrp="1"/>
           </p:cNvGraphicFramePr>
           <p:nvPr/>
         </p:nvGraphicFramePr>
         <p:xfrm>
-          <a:off x="365760" y="4251960"/>
-          <a:ext cx="11460175" cy="1828800"/>
+          <a:off x="365760" y="4681728"/>
+          <a:ext cx="11460175" cy="1554480"/>
         </p:xfrm>
         <a:graphic>
           <a:graphicData uri="http://schemas.openxmlformats.org/drawingml/2006/table">
@@ -7740,7 +8322,7 @@
                 <a:gridCol w="1645920"/>
                 <a:gridCol w="9814255"/>
               </a:tblGrid>
-              <a:tr h="365760">
+              <a:tr h="310896">
                 <a:tc>
                   <a:txBody>
                     <a:bodyPr wrap="square"/>
@@ -7830,7 +8412,7 @@
                   </a:tcPr>
                 </a:tc>
               </a:tr>
-              <a:tr h="365760">
+              <a:tr h="310896">
                 <a:tc>
                   <a:txBody>
                     <a:bodyPr wrap="square"/>
@@ -7920,7 +8502,7 @@
                   </a:tcPr>
                 </a:tc>
               </a:tr>
-              <a:tr h="365760">
+              <a:tr h="310896">
                 <a:tc>
                   <a:txBody>
                     <a:bodyPr wrap="square"/>
@@ -8010,7 +8592,7 @@
                   </a:tcPr>
                 </a:tc>
               </a:tr>
-              <a:tr h="365760">
+              <a:tr h="310896">
                 <a:tc>
                   <a:txBody>
                     <a:bodyPr wrap="square"/>
@@ -8100,7 +8682,7 @@
                   </a:tcPr>
                 </a:tc>
               </a:tr>
-              <a:tr h="365760">
+              <a:tr h="310896">
                 <a:tc>
                   <a:txBody>
                     <a:bodyPr wrap="square"/>
@@ -8196,7 +8778,7 @@
       </p:graphicFrame>
       <p:sp>
         <p:nvSpPr>
-          <p:cNvPr id="32" name="TextBox 31"/>
+          <p:cNvPr id="34" name="TextBox 33"/>
           <p:cNvSpPr txBox="1"/>
           <p:nvPr/>
         </p:nvSpPr>
@@ -12019,7 +12601,7 @@
                 <a:ea typeface="Hiragino Kaku Gothic ProN W3"/>
                 <a:cs typeface="Hiragino Kaku Gothic ProN W3"/>
               </a:rPr>
-              <a:t>・n = 20 で GPR の RMSE は 0.091、線形回帰の約 1/5(p.4)</a:t>
+              <a:t>・n = 20 で GPR の RMSE は 0.091、線形回帰より 82% 小さい(p.4)</a:t>
             </a:r>
           </a:p>
           <a:p>

</xml_diff>